<commit_message>
Rewrite speaker notes in plainer, spoken Korean
Co-Authored-By: Claude Opus 5.5 <noreply@anthropic.com>
Claude-Session: https://claude.ai/code/session_01VWyfvPXCzvV2mTdib2g56M
</commit_message>
<xml_diff>
--- a/slides/영유아교육과정의_이해.pptx
+++ b/slides/영유아교육과정의_이해.pptx
@@ -507,7 +507,9 @@
           <a:p>
             <a:r>
               <a:rPr lang="en-US" dirty="0"/>
-              <a:t>안녕하세요. 오늘은 5장 교육과정의 계획과 운영 중에서 "영유아교육과정의 이해"를 발표하겠습니다. 교육과정이 무엇인지 정의를 먼저 살펴보고, 유치원의 누리과정과 어린이집의 표준보육과정이 어떻게 변해 왔는지, 그리고 2019 개정 누리과정의 핵심 방향을 차례로 말씀드리겠습니다.</a:t>
+              <a:t>안녕하세요. 오늘 제가 발표할 내용은 '영유아교육과정의 이해'입니다.
+쉽게 말하면, 유치원과 어린이집에서 아이들에게 '무엇을, 어떻게 가르칠지' 정해 놓은 계획에 대한 이야기예요.
+먼저 교육과정이 무슨 뜻인지 알아보고, 유치원과 어린이집의 교육과정이 어떻게 바뀌어 왔는지 살펴본 뒤, 마지막으로 요즘 누리과정이 어떤 방향인지 말씀드리겠습니다.</a:t>
             </a:r>
             <a:endParaRPr lang="en-US" dirty="0"/>
           </a:p>
@@ -595,10 +597,10 @@
           <a:p>
             <a:r>
               <a:rPr lang="en-US" dirty="0"/>
-              <a:t>교육과정이란 목표와 일정한 순서로 배열된 학습의 코스와 더불어 교육내용이나 경험내용을 의미합니다.
-이귀윤(1990)에 따르면 교사를 중심으로 보면 가르치는 내용, 교과, 의도적 계획으로 정의되고, 배우는 학생을 중심으로 보면 학습경험 또는 학습 결과로 정의됩니다.
-방인옥 등(1999)은 교육과정을 "학습자의 전인적 성장과 발달을 돕기 위해서 학교가 의미하는 교육적 상황을 마련하고 모든 종류의 교수-학습 경험을 체계적으로 구성한 설계도"라고 정의했습니다.
-넓은 의미로는 학생이 경험하는 모든 것, 좁은 의미로는 계획된 교과목 또는 교수요목을 말합니다.</a:t>
+              <a:t>교육과정이라는 말, 많이 들어 보셨죠? 간단히 말하면 '무엇을, 어떤 순서로 가르치고 배울지 정리한 것'입니다.
+그런데 누구 입장에서 보느냐에 따라 뜻이 조금 달라져요. 선생님 입장에서 보면 '가르칠 내용과 계획'이고, 학생 입장에서 보면 '실제로 배우고 경험한 것'입니다(이귀윤, 1990).
+오른쪽 그림을 보시면, 넓게 보면 학생이 경험하는 모든 것이 교육과정이고, 좁게 보면 미리 짜 놓은 과목이나 수업 계획만을 말합니다.
+방인옥 등(1999)은 교육과정을 '아이가 몸과 마음 모두 골고루 자라도록 돕기 위해, 가르치고 배우는 경험을 잘 짜 놓은 설계도'라고 했습니다. 집을 지을 때 설계도가 필요하듯이, 교육에도 설계도가 필요하다는 뜻이에요.</a:t>
             </a:r>
             <a:endParaRPr lang="en-US" dirty="0"/>
           </a:p>
@@ -686,9 +688,11 @@
           <a:p>
             <a:r>
               <a:rPr lang="en-US" dirty="0"/>
-              <a:t>우리나라 유치원교육과정은 1969년 처음 제정된 이후 2007년까지 여섯 차례 개정되었습니다.
-현재는 유치원과 어린이집 3~5세를 위한 공통교육과정인 누리과정을 시행하고 있습니다. 누리과정은 그동안 이원화되어 있던 유치원교육과정과 어린이집 표준보육과정을 일원화하여, 취학 전 교육의 질을 높이고 생애초기 출발점 평등을 보장하려는 취지로 개발되었습니다(교육과학기술부·보건복지부, 2012; 2013; 2019).
-2013년에는 만 3~5세 유아를 위한 누리과정이 시행되었고, 2020년부터는 유아중심·놀이중심의 개정 누리과정이 적용되고 있습니다.</a:t>
+              <a:t>그럼 유치원 교육과정은 어떻게 바뀌어 왔을까요?
+우리나라 유치원 교육과정은 1969년에 처음 만들어졌고, 2007년까지 모두 여섯 번 고쳐졌습니다.
+그런데 예전에는 유치원은 유치원 교육과정, 어린이집은 표준보육과정, 이렇게 따로따로였어요. 같은 나이의 아이인데도 다니는 곳에 따라 배우는 내용이 달랐던 거죠.
+그래서 둘을 하나로 합친 것이 바로 '누리과정'입니다. 목적은 두 가지예요. 첫째, 초등학교에 들어가기 전 교육의 질을 높이는 것. 둘째, 어디에 다니든 모든 아이가 같은 출발선에서 시작할 수 있게 하는 것입니다.
+누리과정은 2013년부터 만 3~5세 아이들에게 적용되었고, 2020년부터는 '아이 중심, 놀이 중심'으로 바뀐 개정 누리과정을 쓰고 있습니다.</a:t>
             </a:r>
             <a:endParaRPr lang="en-US" dirty="0"/>
           </a:p>
@@ -776,9 +780,10 @@
           <a:p>
             <a:r>
               <a:rPr lang="en-US" dirty="0"/>
-              <a:t>어린이집은 국가수준 보육과정으로 표준보육과정이 보급되었습니다. 표준보육과정은 어린이집에서 영유아가 경험해야 할 바람직한 태도와 가치, 지식, 기술 등을 제시한 국가수준의 보편적 교육과정입니다.
-1990년대 후반 어린이집이 양적으로 늘어난 것과 관련이 있습니다. 핵가족화, 취업모의 증가, 그리고 출생 후 조기 경험이 발달에 결정적이라는 인식이 커지면서 어린이집 이용이 보편화되었고, 보육은 사회적 계층이나 부모의 취업 여부와 관계없이 모든 영유아에게 보호와 교육을 제공하는 것으로 바뀌었습니다. 그래서 국가수준의 지침이 필요해졌습니다.
-2004년 1월 29일 전면 개정된 영유아보육법 제29조 제2항에 표준보육과정 개발·보급이 명시되었고, 2007년 공포, 2013년 제3차 개정(보건복지부, 2013b), 2020년 제4차 고시(보건복지부, 2020)가 이루어졌습니다. 2025년에는 유보통합 실행계획(안)에 따라 0~5세 영유아교육과정이 마련되기 전, 2024 개정 표준보육과정(0~2세)이 고시되었습니다.</a:t>
+              <a:t>이번에는 어린이집의 표준보육과정입니다. 표준보육과정은 어린이집에서 아이들이 배우고 경험해야 할 것을 나라에서 정해 놓은 기준이에요.
+왜 필요해졌을까요? 1990년대 후반부터 어린이집이 크게 늘었습니다. 핵가족이 많아지고, 일하는 엄마들도 계속 늘었고, 어릴 때의 경험이 아이 발달에 아주 중요하다는 생각도 커졌기 때문이에요.
+이제 어린이집은 일부 가정만 보내는 곳이 아니라, 누구나 다니는 곳이 되었습니다. 그러다 보니 '어린이집마다 제각각 하지 말고, 나라에서 공통 기준을 정해 주자'는 필요가 생긴 거죠.
+그래서 2004년 영유아보육법에 '표준보육과정을 만들어 보급해야 한다'는 내용이 들어갔고, 2007년에 처음 발표되었습니다. 이후 2013년에 3차, 2020년에 4차로 바뀌었고, 2025년에는 0~2세 아이들을 위한 2024 개정 표준보육과정이 나왔습니다.</a:t>
             </a:r>
             <a:endParaRPr lang="en-US" dirty="0"/>
           </a:p>
@@ -866,12 +871,11 @@
           <a:p>
             <a:r>
               <a:rPr lang="en-US" dirty="0"/>
-              <a:t>유치원과 어린이집의 공통교육과정인 2019 개정 누리과정은 교육부가 출발선 평등을 실현하기 위한 "유아교육 혁신방안"에 의거해 개정한 것입니다.
-혁신 방향은 세 가지입니다.
-첫째, 초등학교 준비 위주의 학습보다는 개별 유아의 다양한 특성을 고려한 내용으로 구성해야 한다.
-둘째, 교사계획서 위주, 학습 위주의 교육보다는 유아의 자유놀이를 권장하며 관찰과 기록 등 유아와의 상호작용을 강조해야 한다.
-셋째, 5개 영역, 주제-소주제 등 구성체계가 지나치게 세부적이므로 현장의 자율성을 존중하기 위해 세부내용을 삭제해야 한다(교육부, 2017).
-이 방향을 반영해 "유아 중심·놀이 중심 교육과정"으로 개정된 누리과정이 2020년부터 유치원과 어린이집 공통교육과정으로 적용되고 있습니다.</a:t>
+              <a:t>그럼 지금 쓰고 있는 2019 개정 누리과정은 무엇이 달라졌을까요? 모든 아이가 같은 출발선에서 시작하게 하자는 교육부의 계획(교육부, 2017)에 따라 바뀌었고, 크게 세 가지가 달라졌습니다.
+첫째, 초등학교 공부를 미리 준비시키는 대신, 아이 한 명 한 명의 특성을 살피도록 했습니다.
+둘째, 선생님이 짜 놓은 계획대로 가르치기보다 아이들이 자유롭게 놀게 하고, 선생님은 옆에서 잘 지켜보고 기록하면서 함께하도록 했습니다.
+셋째, 예전에는 5개 영역, 주제, 소주제처럼 너무 자세하게 정해져 있었는데, 이것을 줄여서 현장 선생님들이 상황에 맞게 판단할 수 있게 했습니다.
+한마디로 '아이 중심, 놀이 중심'이고, 2020년부터 유치원과 어린이집 모두에서 쓰이고 있습니다.</a:t>
             </a:r>
             <a:endParaRPr lang="en-US" dirty="0"/>
           </a:p>
@@ -959,11 +963,12 @@
           <a:p>
             <a:r>
               <a:rPr lang="en-US" dirty="0"/>
-              <a:t>정리하겠습니다. 현재 0~2세 영아는 어린이집 표준보육과정을, 3~5세 유아는 유치원과 어린이집 공통의 누리과정을 따릅니다.
-첫째, 교육과정은 학습자의 전인적 성장과 발달을 위한 교수-학습 경험의 설계도입니다.
-둘째, 누리과정은 이원화되어 있던 유치원교육과정과 표준보육과정을 일원화해 교육의 질과 출발점 평등을 보장하려는 것입니다.
-셋째, 2019 개정 누리과정은 유아 중심·놀이 중심으로, 현장의 자율성을 존중합니다.
-이상으로 발표를 마치겠습니다. 감사합니다.</a:t>
+              <a:t>마지막으로 정리하겠습니다. 지금 0~2세 아이들은 어린이집 표준보육과정을, 3~5세 아이들은 유치원이든 어린이집이든 똑같이 누리과정을 따릅니다.
+세 가지만 기억해 주세요.
+하나, 교육과정은 아이가 골고루 자라도록 돕는 교육의 설계도입니다.
+둘, 누리과정은 따로 있던 유치원과 어린이집의 교육과정을 하나로 합친 것입니다.
+셋, 2019 개정 누리과정의 핵심은 아이 중심, 놀이 중심입니다.
+이상으로 발표를 마치겠습니다. 들어 주셔서 감사합니다.</a:t>
             </a:r>
             <a:endParaRPr lang="en-US" dirty="0"/>
           </a:p>

</xml_diff>